<commit_message>
Add Grad-CAM example slide to viva deck; add PDF export
- Insert a Grad-CAM example slide (slide 14): per-model attention maps, a
  consensus map, and a worked EAA-IoU agreement example. Figure is a clearly
  labelled illustrative schematic; deck now has 17 slides.
- Provide the deck as PDF (rendered via headless Chromium, since LibreOffice
  cannot convert in this environment) alongside the editable .pptx.

Co-Authored-By: Claude Opus 4.8 <noreply@anthropic.com>
Claude-Session: https://claude.ai/code/session_01M7N66RkYRrCkyAfYAS5cMb
</commit_message>
<xml_diff>
--- a/Interim_Viva/Interim_Viva_E187041.pptx
+++ b/Interim_Viva/Interim_Viva_E187041.pptx
@@ -21,9 +21,10 @@
     <p:sldId id="269" r:id="rId15"/>
     <p:sldId id="270" r:id="rId16"/>
     <p:sldId id="271" r:id="rId17"/>
+    <p:sldId id="272" r:id="rId18"/>
   </p:sldIdLst>
   <p:notesMasterIdLst>
-    <p:notesMasterId r:id="rId18"/>
+    <p:notesMasterId r:id="rId19"/>
   </p:notesMasterIdLst>
   <p:sldSz cx="12192000" cy="6858000"/>
   <p:notesSz cx="6858000" cy="12192000"/>
@@ -957,7 +958,7 @@
           <a:p>
             <a:r>
               <a:rPr lang="en-US" dirty="0"/>
-              <a:t>How you built it: separation of concerns. Training code is independent of the app; the app only consumes saved models. Why Hugging Face: model files exceed GitHub limits, and it also hosts the result galleries. Known issue I can speak to: the deployed app needs HF_REPO_ID set to auto-download the models, otherwise it reports no models loaded. Insert a real screenshot of the running app here before the viva.</a:t>
+              <a:t>Why a schematic and not real output: live Grad-CAM needs all three deep models loaded; I generate real heatmaps in the app, and will swap real exported panels into this slide before submission. How EAA-IoU is read: it is the mean of the three pairwise IoU values; high means the models look at the same region. Question: what threshold flags a case? I use 0.40 as a starting point and will report sensitivity to it on the test set. Question: could models agree and all be wrong? Possible, which is why EAA-IoU is a safety signal on top of the prediction, not a replacement for it.</a:t>
             </a:r>
             <a:endParaRPr lang="en-US" dirty="0"/>
           </a:p>
@@ -1045,7 +1046,7 @@
           <a:p>
             <a:r>
               <a:rPr lang="en-US" dirty="0"/>
-              <a:t>Risk question: what if EAA-IoU does not correlate with error? Answer: that is still a valid, reportable research finding, and the confidence-weighted vote remains a useful deliverable. Compute risk for Xception is handled with cloud GPU. End on confidence that the project finishes on time.</a:t>
+              <a:t>How you built it: separation of concerns. Training code is independent of the app; the app only consumes saved models. Why Hugging Face: model files exceed GitHub limits, and it also hosts the result galleries. Known issue I can speak to: the deployed app needs HF_REPO_ID set to auto-download the models, otherwise it reports no models loaded. Insert a real screenshot of the running app here before the viva.</a:t>
             </a:r>
             <a:endParaRPr lang="en-US" dirty="0"/>
           </a:p>
@@ -1133,7 +1134,7 @@
           <a:p>
             <a:r>
               <a:rPr lang="en-US" dirty="0"/>
-              <a:t>Anticipated questions to rehearse: (1) Why these three architectures? comparative RQ + diverse backbones for agreement. (2) What exactly is novel? inter-model Grad-CAM IoU as a label-free uncertainty signal. (3) How does feature extraction work in code? Model(inputs, outputs=get_layer(name).output). (4) Why is the pretrained model weaker than the CNN? frozen heads undertrained; fine-tuning next. (5) Why 98.2 percent is not shown? needs Xception, reported honestly at interim. (6) How is the software structured? training modules, Hugging Face hosting, FastAPI/Streamlit app. (7) Fairness? one pipeline, one seed, official test split. (8) Ethics? public anonymised data, decision-support not replacement.</a:t>
+              <a:t>Risk question: what if EAA-IoU does not correlate with error? Answer: that is still a valid, reportable research finding, and the confidence-weighted vote remains a useful deliverable. Compute risk for Xception is handled with cloud GPU. End on confidence that the project finishes on time.</a:t>
             </a:r>
             <a:endParaRPr lang="en-US" dirty="0"/>
           </a:p>
@@ -1157,6 +1158,94 @@
             <a:fld id="{F7021451-1387-4CA6-816F-3879F97B5CBC}" type="slidenum">
               <a:rPr lang="en-US"/>
               <a:t>16</a:t>
+            </a:fld>
+            <a:endParaRPr lang="en-US"/>
+          </a:p>
+        </p:txBody>
+      </p:sp>
+    </p:spTree>
+    <p:extLst>
+      <p:ext uri="{BB962C8B-B14F-4D97-AF65-F5344CB8AC3E}">
+        <p14:creationId xmlns:p14="http://schemas.microsoft.com/office/powerpoint/2010/main" val="1024086991"/>
+      </p:ext>
+    </p:extLst>
+  </p:cSld>
+  <p:clrMapOvr>
+    <a:masterClrMapping/>
+  </p:clrMapOvr>
+</p:notes>
+</file>
+
+<file path=ppt/notesSlides/notesSlide17.xml><?xml version="1.0" encoding="utf-8"?>
+<p:notes xmlns:a="http://schemas.openxmlformats.org/drawingml/2006/main" xmlns:r="http://schemas.openxmlformats.org/officeDocument/2006/relationships" xmlns:p="http://schemas.openxmlformats.org/presentationml/2006/main">
+  <p:cSld>
+    <p:spTree>
+      <p:nvGrpSpPr>
+        <p:cNvPr id="1" name=""/>
+        <p:cNvGrpSpPr/>
+        <p:nvPr/>
+      </p:nvGrpSpPr>
+      <p:grpSpPr>
+        <a:xfrm>
+          <a:off x="0" y="0"/>
+          <a:ext cx="0" cy="0"/>
+          <a:chOff x="0" y="0"/>
+          <a:chExt cx="0" cy="0"/>
+        </a:xfrm>
+      </p:grpSpPr>
+      <p:sp>
+        <p:nvSpPr>
+          <p:cNvPr id="2" name="Slide Image Placeholder 1"/>
+          <p:cNvSpPr>
+            <a:spLocks noGrp="1" noRot="1" noChangeAspect="1"/>
+          </p:cNvSpPr>
+          <p:nvPr>
+            <p:ph type="sldImg"/>
+          </p:nvPr>
+        </p:nvSpPr>
+        <p:spPr/>
+      </p:sp>
+      <p:sp>
+        <p:nvSpPr>
+          <p:cNvPr id="3" name="Notes Placeholder 2"/>
+          <p:cNvSpPr>
+            <a:spLocks noGrp="1"/>
+          </p:cNvSpPr>
+          <p:nvPr>
+            <p:ph type="body" idx="1"/>
+          </p:nvPr>
+        </p:nvSpPr>
+        <p:spPr/>
+        <p:txBody>
+          <a:bodyPr/>
+          <a:lstStyle/>
+          <a:p>
+            <a:r>
+              <a:rPr lang="en-US" dirty="0"/>
+              <a:t>Anticipated questions to rehearse: (1) Why these three architectures? comparative RQ + diverse backbones for agreement. (2) What exactly is novel? inter-model Grad-CAM IoU as a label-free uncertainty signal. (3) How does feature extraction work in code? Model(inputs, outputs=get_layer(name).output). (4) Why is the pretrained model weaker than the CNN? frozen heads undertrained; fine-tuning next. (5) Why 98.2 percent is not shown? needs Xception, reported honestly at interim. (6) How is the software structured? training modules, Hugging Face hosting, FastAPI/Streamlit app. (7) Fairness? one pipeline, one seed, official test split. (8) Ethics? public anonymised data, decision-support not replacement.</a:t>
+            </a:r>
+            <a:endParaRPr lang="en-US" dirty="0"/>
+          </a:p>
+        </p:txBody>
+      </p:sp>
+      <p:sp>
+        <p:nvSpPr>
+          <p:cNvPr id="4" name="Slide Number Placeholder 3"/>
+          <p:cNvSpPr>
+            <a:spLocks noGrp="1"/>
+          </p:cNvSpPr>
+          <p:nvPr>
+            <p:ph type="sldNum" sz="quarter" idx="10"/>
+          </p:nvPr>
+        </p:nvSpPr>
+        <p:spPr/>
+        <p:txBody>
+          <a:bodyPr/>
+          <a:lstStyle/>
+          <a:p>
+            <a:fld id="{F7021451-1387-4CA6-816F-3879F97B5CBC}" type="slidenum">
+              <a:rPr lang="en-US"/>
+              <a:t>17</a:t>
             </a:fld>
             <a:endParaRPr lang="en-US"/>
           </a:p>
@@ -5020,7 +5109,7 @@
                 <a:ea typeface="Cambria" pitchFamily="34" charset="-122"/>
                 <a:cs typeface="Cambria" pitchFamily="34" charset="-120"/>
               </a:rPr>
-              <a:t>How the Software Is Built</a:t>
+              <a:t>Grad-CAM Example and Agreement</a:t>
             </a:r>
             <a:endParaRPr lang="en-US" sz="3000" dirty="0"/>
           </a:p>
@@ -5104,43 +5193,40 @@
           </a:p>
         </p:txBody>
       </p:sp>
-      <p:sp>
-        <p:nvSpPr>
-          <p:cNvPr id="5" name="Shape 3"/>
-          <p:cNvSpPr/>
-          <p:nvPr/>
-        </p:nvSpPr>
-        <p:spPr>
-          <a:xfrm>
-            <a:off x="548640" y="1463040"/>
-            <a:ext cx="2743200" cy="1097280"/>
-          </a:xfrm>
-          <a:prstGeom prst="roundRect">
-            <a:avLst>
-              <a:gd name="adj" fmla="val 5000"/>
-            </a:avLst>
-          </a:prstGeom>
-          <a:solidFill>
-            <a:srgbClr val="1E3A5F"/>
-          </a:solidFill>
-          <a:ln w="12700">
-            <a:solidFill>
-              <a:srgbClr val="1E3A5F"/>
-            </a:solidFill>
-            <a:prstDash val="solid"/>
-          </a:ln>
-        </p:spPr>
-      </p:sp>
-      <p:sp>
-        <p:nvSpPr>
-          <p:cNvPr id="6" name="Text 4"/>
+      <p:pic>
+        <p:nvPicPr>
+          <p:cNvPr id="5" name="Image 0" descr="/home/user/LMU_Research/Interim_Report/figures/gradcam_example.png">    </p:cNvPr>
+          <p:cNvPicPr>
+            <a:picLocks noChangeAspect="1"/>
+          </p:cNvPicPr>
+          <p:nvPr/>
+        </p:nvPicPr>
+        <p:blipFill>
+          <a:blip r:embed="rId1"/>
+          <a:stretch>
+            <a:fillRect/>
+          </a:stretch>
+        </p:blipFill>
+        <p:spPr>
+          <a:xfrm>
+            <a:off x="594360" y="1371600"/>
+            <a:ext cx="10972800" cy="2679192"/>
+          </a:xfrm>
+          <a:prstGeom prst="rect">
+            <a:avLst/>
+          </a:prstGeom>
+        </p:spPr>
+      </p:pic>
+      <p:sp>
+        <p:nvSpPr>
+          <p:cNvPr id="6" name="Text 3"/>
           <p:cNvSpPr txBox="1"/>
           <p:nvPr/>
         </p:nvSpPr>
         <p:spPr>
           <a:xfrm>
-            <a:off x="621792" y="1463040"/>
-            <a:ext cx="2596896" cy="1097280"/>
+            <a:off x="594360" y="4096512"/>
+            <a:ext cx="10972800" cy="274320"/>
           </a:xfrm>
           <a:prstGeom prst="rect">
             <a:avLst/>
@@ -5156,291 +5242,30 @@
               <a:buNone/>
             </a:pPr>
             <a:r>
-              <a:rPr lang="en-US" sz="1300" b="1" dirty="0">
-                <a:solidFill>
-                  <a:srgbClr val="FFFFFF"/>
-                </a:solidFill>
-                <a:latin typeface="Calibri" pitchFamily="34" charset="0"/>
-                <a:ea typeface="Calibri" pitchFamily="34" charset="-122"/>
-                <a:cs typeface="Calibri" pitchFamily="34" charset="-120"/>
-              </a:rPr>
-              <a:t>Training modules</a:t>
-            </a:r>
-            <a:endParaRPr lang="en-US" sz="1300" dirty="0"/>
-          </a:p>
-          <a:p>
-            <a:pPr algn="ctr" indent="0" marL="0">
-              <a:buNone/>
-            </a:pPr>
-            <a:r>
-              <a:rPr lang="en-US" sz="950" dirty="0">
-                <a:solidFill>
-                  <a:srgbClr val="CFE0DA"/>
-                </a:solidFill>
-                <a:latin typeface="Calibri" pitchFamily="34" charset="0"/>
-                <a:ea typeface="Calibri" pitchFamily="34" charset="-122"/>
-                <a:cs typeface="Calibri" pitchFamily="34" charset="-120"/>
-              </a:rPr>
-              <a:t>config · data · models · train</a:t>
-            </a:r>
-            <a:endParaRPr lang="en-US" sz="1300" dirty="0"/>
-          </a:p>
-        </p:txBody>
-      </p:sp>
-      <p:sp>
-        <p:nvSpPr>
-          <p:cNvPr id="7" name="Text 5"/>
+              <a:rPr lang="en-US" sz="1000" i="1" dirty="0">
+                <a:solidFill>
+                  <a:srgbClr val="5A6675"/>
+                </a:solidFill>
+                <a:latin typeface="Calibri" pitchFamily="34" charset="0"/>
+                <a:ea typeface="Calibri" pitchFamily="34" charset="-122"/>
+                <a:cs typeface="Calibri" pitchFamily="34" charset="-120"/>
+              </a:rPr>
+              <a:t>Illustrative schematic. Live heatmaps are generated per image in the web application.</a:t>
+            </a:r>
+            <a:endParaRPr lang="en-US" sz="1000" dirty="0"/>
+          </a:p>
+        </p:txBody>
+      </p:sp>
+      <p:sp>
+        <p:nvSpPr>
+          <p:cNvPr id="7" name="Text 4"/>
           <p:cNvSpPr txBox="1"/>
           <p:nvPr/>
         </p:nvSpPr>
         <p:spPr>
           <a:xfrm>
-            <a:off x="3383280" y="1737360"/>
-            <a:ext cx="274320" cy="365760"/>
-          </a:xfrm>
-          <a:prstGeom prst="rect">
-            <a:avLst/>
-          </a:prstGeom>
-          <a:noFill/>
-          <a:ln/>
-        </p:spPr>
-        <p:txBody>
-          <a:bodyPr wrap="square" lIns="0" tIns="0" rIns="0" bIns="0" rtlCol="0" anchor="ctr"/>
-          <a:lstStyle/>
-          <a:p>
-            <a:pPr algn="ctr" indent="0" marL="0">
-              <a:buNone/>
-            </a:pPr>
-            <a:r>
-              <a:rPr lang="en-US" sz="2000" b="1" dirty="0">
-                <a:solidFill>
-                  <a:srgbClr val="2A9D8F"/>
-                </a:solidFill>
-                <a:latin typeface="Calibri" pitchFamily="34" charset="0"/>
-                <a:ea typeface="Calibri" pitchFamily="34" charset="-122"/>
-                <a:cs typeface="Calibri" pitchFamily="34" charset="-120"/>
-              </a:rPr>
-              <a:t>&gt;</a:t>
-            </a:r>
-            <a:endParaRPr lang="en-US" sz="2000" dirty="0"/>
-          </a:p>
-        </p:txBody>
-      </p:sp>
-      <p:sp>
-        <p:nvSpPr>
-          <p:cNvPr id="8" name="Shape 6"/>
-          <p:cNvSpPr/>
-          <p:nvPr/>
-        </p:nvSpPr>
-        <p:spPr>
-          <a:xfrm>
-            <a:off x="3703320" y="1463040"/>
-            <a:ext cx="2468880" cy="1097280"/>
-          </a:xfrm>
-          <a:prstGeom prst="roundRect">
-            <a:avLst>
-              <a:gd name="adj" fmla="val 5000"/>
-            </a:avLst>
-          </a:prstGeom>
-          <a:solidFill>
-            <a:srgbClr val="2A9D8F"/>
-          </a:solidFill>
-          <a:ln w="12700">
-            <a:solidFill>
-              <a:srgbClr val="2A9D8F"/>
-            </a:solidFill>
-            <a:prstDash val="solid"/>
-          </a:ln>
-        </p:spPr>
-      </p:sp>
-      <p:sp>
-        <p:nvSpPr>
-          <p:cNvPr id="9" name="Text 7"/>
-          <p:cNvSpPr txBox="1"/>
-          <p:nvPr/>
-        </p:nvSpPr>
-        <p:spPr>
-          <a:xfrm>
-            <a:off x="3776472" y="1463040"/>
-            <a:ext cx="2322576" cy="1097280"/>
-          </a:xfrm>
-          <a:prstGeom prst="rect">
-            <a:avLst/>
-          </a:prstGeom>
-          <a:noFill/>
-          <a:ln/>
-        </p:spPr>
-        <p:txBody>
-          <a:bodyPr wrap="square" lIns="0" tIns="0" rIns="0" bIns="0" rtlCol="0" anchor="ctr"/>
-          <a:lstStyle/>
-          <a:p>
-            <a:pPr algn="ctr" indent="0" marL="0">
-              <a:buNone/>
-            </a:pPr>
-            <a:r>
-              <a:rPr lang="en-US" sz="1300" b="1" dirty="0">
-                <a:solidFill>
-                  <a:srgbClr val="FFFFFF"/>
-                </a:solidFill>
-                <a:latin typeface="Calibri" pitchFamily="34" charset="0"/>
-                <a:ea typeface="Calibri" pitchFamily="34" charset="-122"/>
-                <a:cs typeface="Calibri" pitchFamily="34" charset="-120"/>
-              </a:rPr>
-              <a:t>Hugging Face Hub</a:t>
-            </a:r>
-            <a:endParaRPr lang="en-US" sz="1300" dirty="0"/>
-          </a:p>
-          <a:p>
-            <a:pPr algn="ctr" indent="0" marL="0">
-              <a:buNone/>
-            </a:pPr>
-            <a:r>
-              <a:rPr lang="en-US" sz="950" dirty="0">
-                <a:solidFill>
-                  <a:srgbClr val="CFE0DA"/>
-                </a:solidFill>
-                <a:latin typeface="Calibri" pitchFamily="34" charset="0"/>
-                <a:ea typeface="Calibri" pitchFamily="34" charset="-122"/>
-                <a:cs typeface="Calibri" pitchFamily="34" charset="-120"/>
-              </a:rPr>
-              <a:t>weights + results</a:t>
-            </a:r>
-            <a:endParaRPr lang="en-US" sz="1300" dirty="0"/>
-          </a:p>
-        </p:txBody>
-      </p:sp>
-      <p:sp>
-        <p:nvSpPr>
-          <p:cNvPr id="10" name="Text 8"/>
-          <p:cNvSpPr txBox="1"/>
-          <p:nvPr/>
-        </p:nvSpPr>
-        <p:spPr>
-          <a:xfrm>
-            <a:off x="6263640" y="1737360"/>
-            <a:ext cx="274320" cy="365760"/>
-          </a:xfrm>
-          <a:prstGeom prst="rect">
-            <a:avLst/>
-          </a:prstGeom>
-          <a:noFill/>
-          <a:ln/>
-        </p:spPr>
-        <p:txBody>
-          <a:bodyPr wrap="square" lIns="0" tIns="0" rIns="0" bIns="0" rtlCol="0" anchor="ctr"/>
-          <a:lstStyle/>
-          <a:p>
-            <a:pPr algn="ctr" indent="0" marL="0">
-              <a:buNone/>
-            </a:pPr>
-            <a:r>
-              <a:rPr lang="en-US" sz="2000" b="1" dirty="0">
-                <a:solidFill>
-                  <a:srgbClr val="2A9D8F"/>
-                </a:solidFill>
-                <a:latin typeface="Calibri" pitchFamily="34" charset="0"/>
-                <a:ea typeface="Calibri" pitchFamily="34" charset="-122"/>
-                <a:cs typeface="Calibri" pitchFamily="34" charset="-120"/>
-              </a:rPr>
-              <a:t>&gt;</a:t>
-            </a:r>
-            <a:endParaRPr lang="en-US" sz="2000" dirty="0"/>
-          </a:p>
-        </p:txBody>
-      </p:sp>
-      <p:sp>
-        <p:nvSpPr>
-          <p:cNvPr id="11" name="Shape 9"/>
-          <p:cNvSpPr/>
-          <p:nvPr/>
-        </p:nvSpPr>
-        <p:spPr>
-          <a:xfrm>
-            <a:off x="6583680" y="1463040"/>
-            <a:ext cx="2743200" cy="1097280"/>
-          </a:xfrm>
-          <a:prstGeom prst="roundRect">
-            <a:avLst>
-              <a:gd name="adj" fmla="val 5000"/>
-            </a:avLst>
-          </a:prstGeom>
-          <a:solidFill>
-            <a:srgbClr val="1E3A5F"/>
-          </a:solidFill>
-          <a:ln w="12700">
-            <a:solidFill>
-              <a:srgbClr val="1E3A5F"/>
-            </a:solidFill>
-            <a:prstDash val="solid"/>
-          </a:ln>
-        </p:spPr>
-      </p:sp>
-      <p:sp>
-        <p:nvSpPr>
-          <p:cNvPr id="12" name="Text 10"/>
-          <p:cNvSpPr txBox="1"/>
-          <p:nvPr/>
-        </p:nvSpPr>
-        <p:spPr>
-          <a:xfrm>
-            <a:off x="6656832" y="1463040"/>
-            <a:ext cx="2596896" cy="1097280"/>
-          </a:xfrm>
-          <a:prstGeom prst="rect">
-            <a:avLst/>
-          </a:prstGeom>
-          <a:noFill/>
-          <a:ln/>
-        </p:spPr>
-        <p:txBody>
-          <a:bodyPr wrap="square" lIns="0" tIns="0" rIns="0" bIns="0" rtlCol="0" anchor="ctr"/>
-          <a:lstStyle/>
-          <a:p>
-            <a:pPr algn="ctr" indent="0" marL="0">
-              <a:buNone/>
-            </a:pPr>
-            <a:r>
-              <a:rPr lang="en-US" sz="1300" b="1" dirty="0">
-                <a:solidFill>
-                  <a:srgbClr val="FFFFFF"/>
-                </a:solidFill>
-                <a:latin typeface="Calibri" pitchFamily="34" charset="0"/>
-                <a:ea typeface="Calibri" pitchFamily="34" charset="-122"/>
-                <a:cs typeface="Calibri" pitchFamily="34" charset="-120"/>
-              </a:rPr>
-              <a:t>Web app</a:t>
-            </a:r>
-            <a:endParaRPr lang="en-US" sz="1300" dirty="0"/>
-          </a:p>
-          <a:p>
-            <a:pPr algn="ctr" indent="0" marL="0">
-              <a:buNone/>
-            </a:pPr>
-            <a:r>
-              <a:rPr lang="en-US" sz="950" dirty="0">
-                <a:solidFill>
-                  <a:srgbClr val="CFE0DA"/>
-                </a:solidFill>
-                <a:latin typeface="Calibri" pitchFamily="34" charset="0"/>
-                <a:ea typeface="Calibri" pitchFamily="34" charset="-122"/>
-                <a:cs typeface="Calibri" pitchFamily="34" charset="-120"/>
-              </a:rPr>
-              <a:t>FastAPI + React / Streamlit</a:t>
-            </a:r>
-            <a:endParaRPr lang="en-US" sz="1300" dirty="0"/>
-          </a:p>
-        </p:txBody>
-      </p:sp>
-      <p:sp>
-        <p:nvSpPr>
-          <p:cNvPr id="13" name="Text 11"/>
-          <p:cNvSpPr txBox="1"/>
-          <p:nvPr/>
-        </p:nvSpPr>
-        <p:spPr>
-          <a:xfrm>
-            <a:off x="548640" y="2834640"/>
-            <a:ext cx="6035040" cy="2377440"/>
+            <a:off x="594360" y="4526280"/>
+            <a:ext cx="6400800" cy="1554480"/>
           </a:xfrm>
           <a:prstGeom prst="rect">
             <a:avLst/>
@@ -5460,7 +5285,7 @@
               <a:buChar char="•"/>
             </a:pPr>
             <a:r>
-              <a:rPr lang="en-US" sz="1300" dirty="0">
+              <a:rPr lang="en-US" sz="1350" dirty="0">
                 <a:solidFill>
                   <a:srgbClr val="1C2733"/>
                 </a:solidFill>
@@ -5468,9 +5293,9 @@
                 <a:ea typeface="Calibri" pitchFamily="34" charset="-122"/>
                 <a:cs typeface="Calibri" pitchFamily="34" charset="-120"/>
               </a:rPr>
-              <a:t>Training is modular Python: one config file fixes every hyperparameter and path.</a:t>
-            </a:r>
-            <a:endParaRPr lang="en-US" sz="1300" dirty="0"/>
+              <a:t>Each model produces its own Grad-CAM map showing the region it used to decide.</a:t>
+            </a:r>
+            <a:endParaRPr lang="en-US" sz="1350" dirty="0"/>
           </a:p>
           <a:p>
             <a:pPr algn="l" marL="203200" indent="-203200">
@@ -5481,7 +5306,7 @@
               <a:buChar char="•"/>
             </a:pPr>
             <a:r>
-              <a:rPr lang="en-US" sz="1300" dirty="0">
+              <a:rPr lang="en-US" sz="1350" dirty="0">
                 <a:solidFill>
                   <a:srgbClr val="1C2733"/>
                 </a:solidFill>
@@ -5489,9 +5314,9 @@
                 <a:ea typeface="Calibri" pitchFamily="34" charset="-122"/>
                 <a:cs typeface="Calibri" pitchFamily="34" charset="-120"/>
               </a:rPr>
-              <a:t>Trained models are versioned on Hugging Face; the app downloads them on first run.</a:t>
-            </a:r>
-            <a:endParaRPr lang="en-US" sz="1300" dirty="0"/>
+              <a:t>Strong overlap between the three maps means the ensemble can be trusted.</a:t>
+            </a:r>
+            <a:endParaRPr lang="en-US" sz="1350" dirty="0"/>
           </a:p>
           <a:p>
             <a:pPr algn="l" marL="203200" indent="-203200">
@@ -5502,7 +5327,7 @@
               <a:buChar char="•"/>
             </a:pPr>
             <a:r>
-              <a:rPr lang="en-US" sz="1300" dirty="0">
+              <a:rPr lang="en-US" sz="1350" dirty="0">
                 <a:solidFill>
                   <a:srgbClr val="1C2733"/>
                 </a:solidFill>
@@ -5510,49 +5335,49 @@
                 <a:ea typeface="Calibri" pitchFamily="34" charset="-122"/>
                 <a:cs typeface="Calibri" pitchFamily="34" charset="-120"/>
               </a:rPr>
-              <a:t>The app runs all models, builds Grad-CAM maps, computes the vote and the EAA-IoU alert.</a:t>
-            </a:r>
-            <a:endParaRPr lang="en-US" sz="1300" dirty="0"/>
-          </a:p>
-        </p:txBody>
-      </p:sp>
-      <p:sp>
-        <p:nvSpPr>
-          <p:cNvPr id="14" name="Shape 12"/>
+              <a:t>When the maps diverge, the EAA-IoU score drops and the case is flagged for review.</a:t>
+            </a:r>
+            <a:endParaRPr lang="en-US" sz="1350" dirty="0"/>
+          </a:p>
+        </p:txBody>
+      </p:sp>
+      <p:sp>
+        <p:nvSpPr>
+          <p:cNvPr id="8" name="Shape 5"/>
           <p:cNvSpPr/>
           <p:nvPr/>
         </p:nvSpPr>
         <p:spPr>
           <a:xfrm>
-            <a:off x="6766560" y="2743200"/>
-            <a:ext cx="4846320" cy="2834640"/>
+            <a:off x="7223760" y="4498848"/>
+            <a:ext cx="4389120" cy="1536192"/>
           </a:xfrm>
           <a:prstGeom prst="roundRect">
             <a:avLst>
-              <a:gd name="adj" fmla="val 1935"/>
+              <a:gd name="adj" fmla="val 3571"/>
             </a:avLst>
           </a:prstGeom>
           <a:solidFill>
-            <a:srgbClr val="FAFBFC"/>
+            <a:srgbClr val="EAF4F1"/>
           </a:solidFill>
-          <a:ln w="15875">
+          <a:ln w="12700">
             <a:solidFill>
-              <a:srgbClr val="2A9D8F"/>
+              <a:srgbClr val="E2E8EF"/>
             </a:solidFill>
-            <a:prstDash val="dash"/>
+            <a:prstDash val="solid"/>
           </a:ln>
         </p:spPr>
       </p:sp>
       <p:sp>
         <p:nvSpPr>
-          <p:cNvPr id="15" name="Text 13"/>
+          <p:cNvPr id="9" name="Text 6"/>
           <p:cNvSpPr txBox="1"/>
           <p:nvPr/>
         </p:nvSpPr>
         <p:spPr>
           <a:xfrm>
-            <a:off x="6949440" y="2743200"/>
-            <a:ext cx="4480560" cy="2834640"/>
+            <a:off x="7406640" y="4608576"/>
+            <a:ext cx="4023360" cy="1335024"/>
           </a:xfrm>
           <a:prstGeom prst="rect">
             <a:avLst/>
@@ -5561,41 +5386,81 @@
           <a:ln/>
         </p:spPr>
         <p:txBody>
-          <a:bodyPr wrap="square" lIns="0" tIns="0" rIns="0" bIns="0" rtlCol="0" anchor="ctr"/>
-          <a:lstStyle/>
-          <a:p>
-            <a:pPr algn="ctr" indent="0" marL="0">
-              <a:buNone/>
-            </a:pPr>
-            <a:r>
-              <a:rPr lang="en-US" sz="1200" b="1" dirty="0">
+          <a:bodyPr wrap="square" lIns="0" tIns="0" rIns="0" bIns="0" rtlCol="0" anchor="t"/>
+          <a:lstStyle/>
+          <a:p>
+            <a:pPr algn="l" indent="0" marL="0">
+              <a:spcAft>
+                <a:spcPts val="600"/>
+              </a:spcAft>
+              <a:buNone/>
+            </a:pPr>
+            <a:r>
+              <a:rPr lang="en-US" sz="1300" b="1" dirty="0">
                 <a:solidFill>
                   <a:srgbClr val="1E6F63"/>
                 </a:solidFill>
-                <a:latin typeface="Calibri" pitchFamily="34" charset="0"/>
-                <a:ea typeface="Calibri" pitchFamily="34" charset="-122"/>
-                <a:cs typeface="Calibri" pitchFamily="34" charset="-120"/>
-              </a:rPr>
-              <a:t>SCREENSHOT PLACEHOLDER</a:t>
-            </a:r>
-            <a:endParaRPr lang="en-US" sz="1200" dirty="0"/>
-          </a:p>
-          <a:p>
-            <a:pPr algn="ctr" indent="0" marL="0">
-              <a:buNone/>
-            </a:pPr>
-            <a:r>
-              <a:rPr lang="en-US" sz="1100" dirty="0">
-                <a:solidFill>
-                  <a:srgbClr val="5A6675"/>
-                </a:solidFill>
-                <a:latin typeface="Calibri" pitchFamily="34" charset="0"/>
-                <a:ea typeface="Calibri" pitchFamily="34" charset="-122"/>
-                <a:cs typeface="Calibri" pitchFamily="34" charset="-120"/>
-              </a:rPr>
-              <a:t>Web application screenshot: upload, prediction, confidence, Grad-CAM panels, class probabilities</a:t>
-            </a:r>
-            <a:endParaRPr lang="en-US" sz="1200" dirty="0"/>
+              </a:rPr>
+              <a:t>Worked example (illustrative)</a:t>
+            </a:r>
+            <a:endParaRPr lang="en-US" sz="1300" dirty="0"/>
+          </a:p>
+          <a:p>
+            <a:pPr algn="l" indent="0" marL="0">
+              <a:spcAft>
+                <a:spcPts val="600"/>
+              </a:spcAft>
+              <a:buNone/>
+            </a:pPr>
+            <a:r>
+              <a:rPr lang="en-US" sz="1200" dirty="0">
+                <a:solidFill>
+                  <a:srgbClr val="1C2733"/>
+                </a:solidFill>
+                <a:latin typeface="Courier New" pitchFamily="34" charset="0"/>
+                <a:ea typeface="Courier New" pitchFamily="34" charset="-122"/>
+                <a:cs typeface="Courier New" pitchFamily="34" charset="-120"/>
+              </a:rPr>
+              <a:t>Pairwise IoU:  0.71,  0.69,  0.73</a:t>
+            </a:r>
+            <a:endParaRPr lang="en-US" sz="1300" dirty="0"/>
+          </a:p>
+          <a:p>
+            <a:pPr algn="l" indent="0" marL="0">
+              <a:spcAft>
+                <a:spcPts val="400"/>
+              </a:spcAft>
+              <a:buNone/>
+            </a:pPr>
+            <a:r>
+              <a:rPr lang="en-US" sz="1300" b="1" dirty="0">
+                <a:solidFill>
+                  <a:srgbClr val="2A9D8F"/>
+                </a:solidFill>
+                <a:latin typeface="Courier New" pitchFamily="34" charset="0"/>
+                <a:ea typeface="Courier New" pitchFamily="34" charset="-122"/>
+                <a:cs typeface="Courier New" pitchFamily="34" charset="-120"/>
+              </a:rPr>
+              <a:t>EAA-IoU = 0.71</a:t>
+            </a:r>
+            <a:endParaRPr lang="en-US" sz="1300" dirty="0"/>
+          </a:p>
+          <a:p>
+            <a:pPr algn="l" indent="0" marL="0">
+              <a:buNone/>
+            </a:pPr>
+            <a:r>
+              <a:rPr lang="en-US" sz="1200" i="1" dirty="0">
+                <a:solidFill>
+                  <a:srgbClr val="1C2733"/>
+                </a:solidFill>
+                <a:latin typeface="Calibri" pitchFamily="34" charset="0"/>
+                <a:ea typeface="Calibri" pitchFamily="34" charset="-122"/>
+                <a:cs typeface="Calibri" pitchFamily="34" charset="-120"/>
+              </a:rPr>
+              <a:t>High agreement, high confidence</a:t>
+            </a:r>
+            <a:endParaRPr lang="en-US" sz="1300" dirty="0"/>
           </a:p>
         </p:txBody>
       </p:sp>
@@ -5664,7 +5529,7 @@
                 <a:ea typeface="Cambria" pitchFamily="34" charset="-122"/>
                 <a:cs typeface="Cambria" pitchFamily="34" charset="-120"/>
               </a:rPr>
-              <a:t>Further Work and Timeline</a:t>
+              <a:t>How the Software Is Built</a:t>
             </a:r>
             <a:endParaRPr lang="en-US" sz="3000" dirty="0"/>
           </a:p>
@@ -5750,14 +5615,341 @@
       </p:sp>
       <p:sp>
         <p:nvSpPr>
-          <p:cNvPr id="5" name="Text 3"/>
+          <p:cNvPr id="5" name="Shape 3"/>
+          <p:cNvSpPr/>
+          <p:nvPr/>
+        </p:nvSpPr>
+        <p:spPr>
+          <a:xfrm>
+            <a:off x="548640" y="1463040"/>
+            <a:ext cx="2743200" cy="1097280"/>
+          </a:xfrm>
+          <a:prstGeom prst="roundRect">
+            <a:avLst>
+              <a:gd name="adj" fmla="val 5000"/>
+            </a:avLst>
+          </a:prstGeom>
+          <a:solidFill>
+            <a:srgbClr val="1E3A5F"/>
+          </a:solidFill>
+          <a:ln w="12700">
+            <a:solidFill>
+              <a:srgbClr val="1E3A5F"/>
+            </a:solidFill>
+            <a:prstDash val="solid"/>
+          </a:ln>
+        </p:spPr>
+      </p:sp>
+      <p:sp>
+        <p:nvSpPr>
+          <p:cNvPr id="6" name="Text 4"/>
           <p:cNvSpPr txBox="1"/>
           <p:nvPr/>
         </p:nvSpPr>
         <p:spPr>
           <a:xfrm>
-            <a:off x="548640" y="1417320"/>
-            <a:ext cx="5760720" cy="3291840"/>
+            <a:off x="621792" y="1463040"/>
+            <a:ext cx="2596896" cy="1097280"/>
+          </a:xfrm>
+          <a:prstGeom prst="rect">
+            <a:avLst/>
+          </a:prstGeom>
+          <a:noFill/>
+          <a:ln/>
+        </p:spPr>
+        <p:txBody>
+          <a:bodyPr wrap="square" lIns="0" tIns="0" rIns="0" bIns="0" rtlCol="0" anchor="ctr"/>
+          <a:lstStyle/>
+          <a:p>
+            <a:pPr algn="ctr" indent="0" marL="0">
+              <a:buNone/>
+            </a:pPr>
+            <a:r>
+              <a:rPr lang="en-US" sz="1300" b="1" dirty="0">
+                <a:solidFill>
+                  <a:srgbClr val="FFFFFF"/>
+                </a:solidFill>
+                <a:latin typeface="Calibri" pitchFamily="34" charset="0"/>
+                <a:ea typeface="Calibri" pitchFamily="34" charset="-122"/>
+                <a:cs typeface="Calibri" pitchFamily="34" charset="-120"/>
+              </a:rPr>
+              <a:t>Training modules</a:t>
+            </a:r>
+            <a:endParaRPr lang="en-US" sz="1300" dirty="0"/>
+          </a:p>
+          <a:p>
+            <a:pPr algn="ctr" indent="0" marL="0">
+              <a:buNone/>
+            </a:pPr>
+            <a:r>
+              <a:rPr lang="en-US" sz="950" dirty="0">
+                <a:solidFill>
+                  <a:srgbClr val="CFE0DA"/>
+                </a:solidFill>
+                <a:latin typeface="Calibri" pitchFamily="34" charset="0"/>
+                <a:ea typeface="Calibri" pitchFamily="34" charset="-122"/>
+                <a:cs typeface="Calibri" pitchFamily="34" charset="-120"/>
+              </a:rPr>
+              <a:t>config · data · models · train</a:t>
+            </a:r>
+            <a:endParaRPr lang="en-US" sz="1300" dirty="0"/>
+          </a:p>
+        </p:txBody>
+      </p:sp>
+      <p:sp>
+        <p:nvSpPr>
+          <p:cNvPr id="7" name="Text 5"/>
+          <p:cNvSpPr txBox="1"/>
+          <p:nvPr/>
+        </p:nvSpPr>
+        <p:spPr>
+          <a:xfrm>
+            <a:off x="3383280" y="1737360"/>
+            <a:ext cx="274320" cy="365760"/>
+          </a:xfrm>
+          <a:prstGeom prst="rect">
+            <a:avLst/>
+          </a:prstGeom>
+          <a:noFill/>
+          <a:ln/>
+        </p:spPr>
+        <p:txBody>
+          <a:bodyPr wrap="square" lIns="0" tIns="0" rIns="0" bIns="0" rtlCol="0" anchor="ctr"/>
+          <a:lstStyle/>
+          <a:p>
+            <a:pPr algn="ctr" indent="0" marL="0">
+              <a:buNone/>
+            </a:pPr>
+            <a:r>
+              <a:rPr lang="en-US" sz="2000" b="1" dirty="0">
+                <a:solidFill>
+                  <a:srgbClr val="2A9D8F"/>
+                </a:solidFill>
+                <a:latin typeface="Calibri" pitchFamily="34" charset="0"/>
+                <a:ea typeface="Calibri" pitchFamily="34" charset="-122"/>
+                <a:cs typeface="Calibri" pitchFamily="34" charset="-120"/>
+              </a:rPr>
+              <a:t>&gt;</a:t>
+            </a:r>
+            <a:endParaRPr lang="en-US" sz="2000" dirty="0"/>
+          </a:p>
+        </p:txBody>
+      </p:sp>
+      <p:sp>
+        <p:nvSpPr>
+          <p:cNvPr id="8" name="Shape 6"/>
+          <p:cNvSpPr/>
+          <p:nvPr/>
+        </p:nvSpPr>
+        <p:spPr>
+          <a:xfrm>
+            <a:off x="3703320" y="1463040"/>
+            <a:ext cx="2468880" cy="1097280"/>
+          </a:xfrm>
+          <a:prstGeom prst="roundRect">
+            <a:avLst>
+              <a:gd name="adj" fmla="val 5000"/>
+            </a:avLst>
+          </a:prstGeom>
+          <a:solidFill>
+            <a:srgbClr val="2A9D8F"/>
+          </a:solidFill>
+          <a:ln w="12700">
+            <a:solidFill>
+              <a:srgbClr val="2A9D8F"/>
+            </a:solidFill>
+            <a:prstDash val="solid"/>
+          </a:ln>
+        </p:spPr>
+      </p:sp>
+      <p:sp>
+        <p:nvSpPr>
+          <p:cNvPr id="9" name="Text 7"/>
+          <p:cNvSpPr txBox="1"/>
+          <p:nvPr/>
+        </p:nvSpPr>
+        <p:spPr>
+          <a:xfrm>
+            <a:off x="3776472" y="1463040"/>
+            <a:ext cx="2322576" cy="1097280"/>
+          </a:xfrm>
+          <a:prstGeom prst="rect">
+            <a:avLst/>
+          </a:prstGeom>
+          <a:noFill/>
+          <a:ln/>
+        </p:spPr>
+        <p:txBody>
+          <a:bodyPr wrap="square" lIns="0" tIns="0" rIns="0" bIns="0" rtlCol="0" anchor="ctr"/>
+          <a:lstStyle/>
+          <a:p>
+            <a:pPr algn="ctr" indent="0" marL="0">
+              <a:buNone/>
+            </a:pPr>
+            <a:r>
+              <a:rPr lang="en-US" sz="1300" b="1" dirty="0">
+                <a:solidFill>
+                  <a:srgbClr val="FFFFFF"/>
+                </a:solidFill>
+                <a:latin typeface="Calibri" pitchFamily="34" charset="0"/>
+                <a:ea typeface="Calibri" pitchFamily="34" charset="-122"/>
+                <a:cs typeface="Calibri" pitchFamily="34" charset="-120"/>
+              </a:rPr>
+              <a:t>Hugging Face Hub</a:t>
+            </a:r>
+            <a:endParaRPr lang="en-US" sz="1300" dirty="0"/>
+          </a:p>
+          <a:p>
+            <a:pPr algn="ctr" indent="0" marL="0">
+              <a:buNone/>
+            </a:pPr>
+            <a:r>
+              <a:rPr lang="en-US" sz="950" dirty="0">
+                <a:solidFill>
+                  <a:srgbClr val="CFE0DA"/>
+                </a:solidFill>
+                <a:latin typeface="Calibri" pitchFamily="34" charset="0"/>
+                <a:ea typeface="Calibri" pitchFamily="34" charset="-122"/>
+                <a:cs typeface="Calibri" pitchFamily="34" charset="-120"/>
+              </a:rPr>
+              <a:t>weights + results</a:t>
+            </a:r>
+            <a:endParaRPr lang="en-US" sz="1300" dirty="0"/>
+          </a:p>
+        </p:txBody>
+      </p:sp>
+      <p:sp>
+        <p:nvSpPr>
+          <p:cNvPr id="10" name="Text 8"/>
+          <p:cNvSpPr txBox="1"/>
+          <p:nvPr/>
+        </p:nvSpPr>
+        <p:spPr>
+          <a:xfrm>
+            <a:off x="6263640" y="1737360"/>
+            <a:ext cx="274320" cy="365760"/>
+          </a:xfrm>
+          <a:prstGeom prst="rect">
+            <a:avLst/>
+          </a:prstGeom>
+          <a:noFill/>
+          <a:ln/>
+        </p:spPr>
+        <p:txBody>
+          <a:bodyPr wrap="square" lIns="0" tIns="0" rIns="0" bIns="0" rtlCol="0" anchor="ctr"/>
+          <a:lstStyle/>
+          <a:p>
+            <a:pPr algn="ctr" indent="0" marL="0">
+              <a:buNone/>
+            </a:pPr>
+            <a:r>
+              <a:rPr lang="en-US" sz="2000" b="1" dirty="0">
+                <a:solidFill>
+                  <a:srgbClr val="2A9D8F"/>
+                </a:solidFill>
+                <a:latin typeface="Calibri" pitchFamily="34" charset="0"/>
+                <a:ea typeface="Calibri" pitchFamily="34" charset="-122"/>
+                <a:cs typeface="Calibri" pitchFamily="34" charset="-120"/>
+              </a:rPr>
+              <a:t>&gt;</a:t>
+            </a:r>
+            <a:endParaRPr lang="en-US" sz="2000" dirty="0"/>
+          </a:p>
+        </p:txBody>
+      </p:sp>
+      <p:sp>
+        <p:nvSpPr>
+          <p:cNvPr id="11" name="Shape 9"/>
+          <p:cNvSpPr/>
+          <p:nvPr/>
+        </p:nvSpPr>
+        <p:spPr>
+          <a:xfrm>
+            <a:off x="6583680" y="1463040"/>
+            <a:ext cx="2743200" cy="1097280"/>
+          </a:xfrm>
+          <a:prstGeom prst="roundRect">
+            <a:avLst>
+              <a:gd name="adj" fmla="val 5000"/>
+            </a:avLst>
+          </a:prstGeom>
+          <a:solidFill>
+            <a:srgbClr val="1E3A5F"/>
+          </a:solidFill>
+          <a:ln w="12700">
+            <a:solidFill>
+              <a:srgbClr val="1E3A5F"/>
+            </a:solidFill>
+            <a:prstDash val="solid"/>
+          </a:ln>
+        </p:spPr>
+      </p:sp>
+      <p:sp>
+        <p:nvSpPr>
+          <p:cNvPr id="12" name="Text 10"/>
+          <p:cNvSpPr txBox="1"/>
+          <p:nvPr/>
+        </p:nvSpPr>
+        <p:spPr>
+          <a:xfrm>
+            <a:off x="6656832" y="1463040"/>
+            <a:ext cx="2596896" cy="1097280"/>
+          </a:xfrm>
+          <a:prstGeom prst="rect">
+            <a:avLst/>
+          </a:prstGeom>
+          <a:noFill/>
+          <a:ln/>
+        </p:spPr>
+        <p:txBody>
+          <a:bodyPr wrap="square" lIns="0" tIns="0" rIns="0" bIns="0" rtlCol="0" anchor="ctr"/>
+          <a:lstStyle/>
+          <a:p>
+            <a:pPr algn="ctr" indent="0" marL="0">
+              <a:buNone/>
+            </a:pPr>
+            <a:r>
+              <a:rPr lang="en-US" sz="1300" b="1" dirty="0">
+                <a:solidFill>
+                  <a:srgbClr val="FFFFFF"/>
+                </a:solidFill>
+                <a:latin typeface="Calibri" pitchFamily="34" charset="0"/>
+                <a:ea typeface="Calibri" pitchFamily="34" charset="-122"/>
+                <a:cs typeface="Calibri" pitchFamily="34" charset="-120"/>
+              </a:rPr>
+              <a:t>Web app</a:t>
+            </a:r>
+            <a:endParaRPr lang="en-US" sz="1300" dirty="0"/>
+          </a:p>
+          <a:p>
+            <a:pPr algn="ctr" indent="0" marL="0">
+              <a:buNone/>
+            </a:pPr>
+            <a:r>
+              <a:rPr lang="en-US" sz="950" dirty="0">
+                <a:solidFill>
+                  <a:srgbClr val="CFE0DA"/>
+                </a:solidFill>
+                <a:latin typeface="Calibri" pitchFamily="34" charset="0"/>
+                <a:ea typeface="Calibri" pitchFamily="34" charset="-122"/>
+                <a:cs typeface="Calibri" pitchFamily="34" charset="-120"/>
+              </a:rPr>
+              <a:t>FastAPI + React / Streamlit</a:t>
+            </a:r>
+            <a:endParaRPr lang="en-US" sz="1300" dirty="0"/>
+          </a:p>
+        </p:txBody>
+      </p:sp>
+      <p:sp>
+        <p:nvSpPr>
+          <p:cNvPr id="13" name="Text 11"/>
+          <p:cNvSpPr txBox="1"/>
+          <p:nvPr/>
+        </p:nvSpPr>
+        <p:spPr>
+          <a:xfrm>
+            <a:off x="548640" y="2834640"/>
+            <a:ext cx="6035040" cy="2377440"/>
           </a:xfrm>
           <a:prstGeom prst="rect">
             <a:avLst/>
@@ -5777,7 +5969,7 @@
               <a:buChar char="•"/>
             </a:pPr>
             <a:r>
-              <a:rPr lang="en-US" sz="1450" dirty="0">
+              <a:rPr lang="en-US" sz="1300" dirty="0">
                 <a:solidFill>
                   <a:srgbClr val="1C2733"/>
                 </a:solidFill>
@@ -5785,9 +5977,9 @@
                 <a:ea typeface="Calibri" pitchFamily="34" charset="-122"/>
                 <a:cs typeface="Calibri" pitchFamily="34" charset="-120"/>
               </a:rPr>
-              <a:t>Train Xception and complete the six-model integrated ensemble.</a:t>
-            </a:r>
-            <a:endParaRPr lang="en-US" sz="1450" dirty="0"/>
+              <a:t>Training is modular Python: one config file fixes every hyperparameter and path.</a:t>
+            </a:r>
+            <a:endParaRPr lang="en-US" sz="1300" dirty="0"/>
           </a:p>
           <a:p>
             <a:pPr algn="l" marL="203200" indent="-203200">
@@ -5798,7 +5990,7 @@
               <a:buChar char="•"/>
             </a:pPr>
             <a:r>
-              <a:rPr lang="en-US" sz="1450" dirty="0">
+              <a:rPr lang="en-US" sz="1300" dirty="0">
                 <a:solidFill>
                   <a:srgbClr val="1C2733"/>
                 </a:solidFill>
@@ -5806,9 +5998,9 @@
                 <a:ea typeface="Calibri" pitchFamily="34" charset="-122"/>
                 <a:cs typeface="Calibri" pitchFamily="34" charset="-120"/>
               </a:rPr>
-              <a:t>Implement confidence-weighted voting for a real per-prediction confidence.</a:t>
-            </a:r>
-            <a:endParaRPr lang="en-US" sz="1450" dirty="0"/>
+              <a:t>Trained models are versioned on Hugging Face; the app downloads them on first run.</a:t>
+            </a:r>
+            <a:endParaRPr lang="en-US" sz="1300" dirty="0"/>
           </a:p>
           <a:p>
             <a:pPr algn="l" marL="203200" indent="-203200">
@@ -5819,7 +6011,7 @@
               <a:buChar char="•"/>
             </a:pPr>
             <a:r>
-              <a:rPr lang="en-US" sz="1450" dirty="0">
+              <a:rPr lang="en-US" sz="1300" dirty="0">
                 <a:solidFill>
                   <a:srgbClr val="1C2733"/>
                 </a:solidFill>
@@ -5827,10 +6019,264 @@
                 <a:ea typeface="Calibri" pitchFamily="34" charset="-122"/>
                 <a:cs typeface="Calibri" pitchFamily="34" charset="-120"/>
               </a:rPr>
-              <a:t>Build and validate EAA-IoU on all test images, with class-wise analysis.</a:t>
-            </a:r>
-            <a:endParaRPr lang="en-US" sz="1450" dirty="0"/>
-          </a:p>
+              <a:t>The app runs all models, builds Grad-CAM maps, computes the vote and the EAA-IoU alert.</a:t>
+            </a:r>
+            <a:endParaRPr lang="en-US" sz="1300" dirty="0"/>
+          </a:p>
+        </p:txBody>
+      </p:sp>
+      <p:sp>
+        <p:nvSpPr>
+          <p:cNvPr id="14" name="Shape 12"/>
+          <p:cNvSpPr/>
+          <p:nvPr/>
+        </p:nvSpPr>
+        <p:spPr>
+          <a:xfrm>
+            <a:off x="6766560" y="2743200"/>
+            <a:ext cx="4846320" cy="2834640"/>
+          </a:xfrm>
+          <a:prstGeom prst="roundRect">
+            <a:avLst>
+              <a:gd name="adj" fmla="val 1935"/>
+            </a:avLst>
+          </a:prstGeom>
+          <a:solidFill>
+            <a:srgbClr val="FAFBFC"/>
+          </a:solidFill>
+          <a:ln w="15875">
+            <a:solidFill>
+              <a:srgbClr val="2A9D8F"/>
+            </a:solidFill>
+            <a:prstDash val="dash"/>
+          </a:ln>
+        </p:spPr>
+      </p:sp>
+      <p:sp>
+        <p:nvSpPr>
+          <p:cNvPr id="15" name="Text 13"/>
+          <p:cNvSpPr txBox="1"/>
+          <p:nvPr/>
+        </p:nvSpPr>
+        <p:spPr>
+          <a:xfrm>
+            <a:off x="6949440" y="2743200"/>
+            <a:ext cx="4480560" cy="2834640"/>
+          </a:xfrm>
+          <a:prstGeom prst="rect">
+            <a:avLst/>
+          </a:prstGeom>
+          <a:noFill/>
+          <a:ln/>
+        </p:spPr>
+        <p:txBody>
+          <a:bodyPr wrap="square" lIns="0" tIns="0" rIns="0" bIns="0" rtlCol="0" anchor="ctr"/>
+          <a:lstStyle/>
+          <a:p>
+            <a:pPr algn="ctr" indent="0" marL="0">
+              <a:buNone/>
+            </a:pPr>
+            <a:r>
+              <a:rPr lang="en-US" sz="1200" b="1" dirty="0">
+                <a:solidFill>
+                  <a:srgbClr val="1E6F63"/>
+                </a:solidFill>
+                <a:latin typeface="Calibri" pitchFamily="34" charset="0"/>
+                <a:ea typeface="Calibri" pitchFamily="34" charset="-122"/>
+                <a:cs typeface="Calibri" pitchFamily="34" charset="-120"/>
+              </a:rPr>
+              <a:t>SCREENSHOT PLACEHOLDER</a:t>
+            </a:r>
+            <a:endParaRPr lang="en-US" sz="1200" dirty="0"/>
+          </a:p>
+          <a:p>
+            <a:pPr algn="ctr" indent="0" marL="0">
+              <a:buNone/>
+            </a:pPr>
+            <a:r>
+              <a:rPr lang="en-US" sz="1100" dirty="0">
+                <a:solidFill>
+                  <a:srgbClr val="5A6675"/>
+                </a:solidFill>
+                <a:latin typeface="Calibri" pitchFamily="34" charset="0"/>
+                <a:ea typeface="Calibri" pitchFamily="34" charset="-122"/>
+                <a:cs typeface="Calibri" pitchFamily="34" charset="-120"/>
+              </a:rPr>
+              <a:t>Web application screenshot: upload, prediction, confidence, Grad-CAM panels, class probabilities</a:t>
+            </a:r>
+            <a:endParaRPr lang="en-US" sz="1200" dirty="0"/>
+          </a:p>
+        </p:txBody>
+      </p:sp>
+    </p:spTree>
+  </p:cSld>
+  <p:clrMapOvr>
+    <a:masterClrMapping/>
+  </p:clrMapOvr>
+</p:sld>
+</file>
+
+<file path=ppt/slides/slide16.xml><?xml version="1.0" encoding="utf-8"?>
+<p:sld xmlns:a="http://schemas.openxmlformats.org/drawingml/2006/main" xmlns:r="http://schemas.openxmlformats.org/officeDocument/2006/relationships" xmlns:p="http://schemas.openxmlformats.org/presentationml/2006/main">
+  <p:cSld name="Slide 16">
+    <p:bg>
+      <p:bgPr>
+        <a:solidFill>
+          <a:srgbClr val="FFFFFF"/>
+        </a:solidFill>
+      </p:bgPr>
+    </p:bg>
+    <p:spTree>
+      <p:nvGrpSpPr>
+        <p:cNvPr id="1" name=""/>
+        <p:cNvGrpSpPr/>
+        <p:nvPr/>
+      </p:nvGrpSpPr>
+      <p:grpSpPr>
+        <a:xfrm>
+          <a:off x="0" y="0"/>
+          <a:ext cx="0" cy="0"/>
+          <a:chOff x="0" y="0"/>
+          <a:chExt cx="0" cy="0"/>
+        </a:xfrm>
+      </p:grpSpPr>
+      <p:sp>
+        <p:nvSpPr>
+          <p:cNvPr id="2" name="Text 0"/>
+          <p:cNvSpPr txBox="1"/>
+          <p:nvPr/>
+        </p:nvSpPr>
+        <p:spPr>
+          <a:xfrm>
+            <a:off x="548640" y="384048"/>
+            <a:ext cx="11091672" cy="731520"/>
+          </a:xfrm>
+          <a:prstGeom prst="rect">
+            <a:avLst/>
+          </a:prstGeom>
+          <a:noFill/>
+          <a:ln/>
+        </p:spPr>
+        <p:txBody>
+          <a:bodyPr wrap="square" lIns="0" tIns="0" rIns="0" bIns="0" rtlCol="0" anchor="ctr"/>
+          <a:lstStyle/>
+          <a:p>
+            <a:pPr algn="l" indent="0" marL="0">
+              <a:buNone/>
+            </a:pPr>
+            <a:r>
+              <a:rPr lang="en-US" sz="3000" b="1" dirty="0">
+                <a:solidFill>
+                  <a:srgbClr val="16263A"/>
+                </a:solidFill>
+                <a:latin typeface="Cambria" pitchFamily="34" charset="0"/>
+                <a:ea typeface="Cambria" pitchFamily="34" charset="-122"/>
+                <a:cs typeface="Cambria" pitchFamily="34" charset="-120"/>
+              </a:rPr>
+              <a:t>Further Work and Timeline</a:t>
+            </a:r>
+            <a:endParaRPr lang="en-US" sz="3000" dirty="0"/>
+          </a:p>
+        </p:txBody>
+      </p:sp>
+      <p:sp>
+        <p:nvSpPr>
+          <p:cNvPr id="3" name="Text 1"/>
+          <p:cNvSpPr txBox="1"/>
+          <p:nvPr/>
+        </p:nvSpPr>
+        <p:spPr>
+          <a:xfrm>
+            <a:off x="548640" y="6473952"/>
+            <a:ext cx="7315200" cy="274320"/>
+          </a:xfrm>
+          <a:prstGeom prst="rect">
+            <a:avLst/>
+          </a:prstGeom>
+          <a:noFill/>
+          <a:ln/>
+        </p:spPr>
+        <p:txBody>
+          <a:bodyPr wrap="square" lIns="0" tIns="0" rIns="0" bIns="0" rtlCol="0" anchor="ctr"/>
+          <a:lstStyle/>
+          <a:p>
+            <a:pPr algn="l" indent="0" marL="0">
+              <a:buNone/>
+            </a:pPr>
+            <a:r>
+              <a:rPr lang="en-US" sz="900" dirty="0">
+                <a:solidFill>
+                  <a:srgbClr val="5A6675"/>
+                </a:solidFill>
+                <a:latin typeface="Calibri" pitchFamily="34" charset="0"/>
+                <a:ea typeface="Calibri" pitchFamily="34" charset="-122"/>
+                <a:cs typeface="Calibri" pitchFamily="34" charset="-120"/>
+              </a:rPr>
+              <a:t>Shehan Kavishka  ·  E187041  ·  CS6P05ES Interim Viva</a:t>
+            </a:r>
+            <a:endParaRPr lang="en-US" sz="900" dirty="0"/>
+          </a:p>
+        </p:txBody>
+      </p:sp>
+      <p:sp>
+        <p:nvSpPr>
+          <p:cNvPr id="4" name="Text 2"/>
+          <p:cNvSpPr txBox="1"/>
+          <p:nvPr/>
+        </p:nvSpPr>
+        <p:spPr>
+          <a:xfrm>
+            <a:off x="11183112" y="6473952"/>
+            <a:ext cx="457200" cy="274320"/>
+          </a:xfrm>
+          <a:prstGeom prst="rect">
+            <a:avLst/>
+          </a:prstGeom>
+          <a:noFill/>
+          <a:ln/>
+        </p:spPr>
+        <p:txBody>
+          <a:bodyPr wrap="square" lIns="0" tIns="0" rIns="0" bIns="0" rtlCol="0" anchor="ctr"/>
+          <a:lstStyle/>
+          <a:p>
+            <a:pPr algn="r" indent="0" marL="0">
+              <a:buNone/>
+            </a:pPr>
+            <a:r>
+              <a:rPr lang="en-US" sz="900" dirty="0">
+                <a:solidFill>
+                  <a:srgbClr val="5A6675"/>
+                </a:solidFill>
+                <a:latin typeface="Calibri" pitchFamily="34" charset="0"/>
+                <a:ea typeface="Calibri" pitchFamily="34" charset="-122"/>
+                <a:cs typeface="Calibri" pitchFamily="34" charset="-120"/>
+              </a:rPr>
+              <a:t>16</a:t>
+            </a:r>
+            <a:endParaRPr lang="en-US" sz="900" dirty="0"/>
+          </a:p>
+        </p:txBody>
+      </p:sp>
+      <p:sp>
+        <p:nvSpPr>
+          <p:cNvPr id="5" name="Text 3"/>
+          <p:cNvSpPr txBox="1"/>
+          <p:nvPr/>
+        </p:nvSpPr>
+        <p:spPr>
+          <a:xfrm>
+            <a:off x="548640" y="1417320"/>
+            <a:ext cx="5760720" cy="3291840"/>
+          </a:xfrm>
+          <a:prstGeom prst="rect">
+            <a:avLst/>
+          </a:prstGeom>
+          <a:noFill/>
+          <a:ln/>
+        </p:spPr>
+        <p:txBody>
+          <a:bodyPr wrap="square" lIns="0" tIns="0" rIns="0" bIns="0" rtlCol="0" anchor="t"/>
+          <a:lstStyle/>
           <a:p>
             <a:pPr algn="l" marL="203200" indent="-203200">
               <a:spcAft>
@@ -5848,6 +6294,69 @@
                 <a:ea typeface="Calibri" pitchFamily="34" charset="-122"/>
                 <a:cs typeface="Calibri" pitchFamily="34" charset="-120"/>
               </a:rPr>
+              <a:t>Train Xception and complete the six-model integrated ensemble.</a:t>
+            </a:r>
+            <a:endParaRPr lang="en-US" sz="1450" dirty="0"/>
+          </a:p>
+          <a:p>
+            <a:pPr algn="l" marL="203200" indent="-203200">
+              <a:spcAft>
+                <a:spcPts val="800"/>
+              </a:spcAft>
+              <a:buSzPct val="100000"/>
+              <a:buChar char="•"/>
+            </a:pPr>
+            <a:r>
+              <a:rPr lang="en-US" sz="1450" dirty="0">
+                <a:solidFill>
+                  <a:srgbClr val="1C2733"/>
+                </a:solidFill>
+                <a:latin typeface="Calibri" pitchFamily="34" charset="0"/>
+                <a:ea typeface="Calibri" pitchFamily="34" charset="-122"/>
+                <a:cs typeface="Calibri" pitchFamily="34" charset="-120"/>
+              </a:rPr>
+              <a:t>Implement confidence-weighted voting for a real per-prediction confidence.</a:t>
+            </a:r>
+            <a:endParaRPr lang="en-US" sz="1450" dirty="0"/>
+          </a:p>
+          <a:p>
+            <a:pPr algn="l" marL="203200" indent="-203200">
+              <a:spcAft>
+                <a:spcPts val="800"/>
+              </a:spcAft>
+              <a:buSzPct val="100000"/>
+              <a:buChar char="•"/>
+            </a:pPr>
+            <a:r>
+              <a:rPr lang="en-US" sz="1450" dirty="0">
+                <a:solidFill>
+                  <a:srgbClr val="1C2733"/>
+                </a:solidFill>
+                <a:latin typeface="Calibri" pitchFamily="34" charset="0"/>
+                <a:ea typeface="Calibri" pitchFamily="34" charset="-122"/>
+                <a:cs typeface="Calibri" pitchFamily="34" charset="-120"/>
+              </a:rPr>
+              <a:t>Build and validate EAA-IoU on all test images, with class-wise analysis.</a:t>
+            </a:r>
+            <a:endParaRPr lang="en-US" sz="1450" dirty="0"/>
+          </a:p>
+          <a:p>
+            <a:pPr algn="l" marL="203200" indent="-203200">
+              <a:spcAft>
+                <a:spcPts val="800"/>
+              </a:spcAft>
+              <a:buSzPct val="100000"/>
+              <a:buChar char="•"/>
+            </a:pPr>
+            <a:r>
+              <a:rPr lang="en-US" sz="1450" dirty="0">
+                <a:solidFill>
+                  <a:srgbClr val="1C2733"/>
+                </a:solidFill>
+                <a:latin typeface="Calibri" pitchFamily="34" charset="0"/>
+                <a:ea typeface="Calibri" pitchFamily="34" charset="-122"/>
+                <a:cs typeface="Calibri" pitchFamily="34" charset="-120"/>
+              </a:rPr>
               <a:t>Finish the web application and collect clinician feedback.</a:t>
             </a:r>
             <a:endParaRPr lang="en-US" sz="1450" dirty="0"/>
@@ -5856,7 +6365,7 @@
       </p:sp>
       <p:graphicFrame>
         <p:nvGraphicFramePr>
-          <p:cNvPr id="16" name="Table 0"/>
+          <p:cNvPr id="17" name="Table 0"/>
           <p:cNvGraphicFramePr>
             <a:graphicFrameLocks noGrp="1"/>
           </p:cNvGraphicFramePr>
@@ -6897,9 +7406,9 @@
 </p:sld>
 </file>
 
-<file path=ppt/slides/slide16.xml><?xml version="1.0" encoding="utf-8"?>
+<file path=ppt/slides/slide17.xml><?xml version="1.0" encoding="utf-8"?>
 <p:sld xmlns:a="http://schemas.openxmlformats.org/drawingml/2006/main" xmlns:r="http://schemas.openxmlformats.org/officeDocument/2006/relationships" xmlns:p="http://schemas.openxmlformats.org/presentationml/2006/main">
-  <p:cSld name="Slide 16">
+  <p:cSld name="Slide 17">
     <p:bg>
       <p:bgPr>
         <a:solidFill>

</xml_diff>